<commit_message>
eproof comms psychol, plots labels
</commit_message>
<xml_diff>
--- a/figures/figure1_v2.pptx
+++ b/figures/figure1_v2.pptx
@@ -112,99 +112,23 @@
 </p:presentation>
 </file>
 
-<file path=ppt/revisionInfo.xml><?xml version="1.0" encoding="utf-8"?>
-<p1510:revInfo xmlns:a="http://schemas.openxmlformats.org/drawingml/2006/main" xmlns:r="http://schemas.openxmlformats.org/officeDocument/2006/relationships" xmlns:p1510="http://schemas.microsoft.com/office/powerpoint/2015/10/main">
-  <p1510:revLst>
-    <p1510:client id="{AE23CADE-1E1E-4A42-BA53-D7F25A2D2BFC}" v="46" dt="2025-08-06T13:42:17.131"/>
-  </p1510:revLst>
-</p1510:revInfo>
-</file>
-
 <file path=ppt/changesInfos/changesInfo1.xml><?xml version="1.0" encoding="utf-8"?>
 <pc:chgInfo xmlns:a="http://schemas.openxmlformats.org/drawingml/2006/main" xmlns:r="http://schemas.openxmlformats.org/officeDocument/2006/relationships" xmlns:ac="http://schemas.microsoft.com/office/drawing/2013/main/command" xmlns:pc="http://schemas.microsoft.com/office/powerpoint/2013/main/command">
   <pc:docChgLst>
-    <pc:chgData name="Castiello de Obeso, Santiago" userId="b4fc0b8e-1f0e-417a-8aad-015961d2398a" providerId="ADAL" clId="{2A3F39FC-901B-4154-829D-ABB3A00DA094}"/>
-    <pc:docChg chg="undo custSel addSld delSld modSld">
-      <pc:chgData name="Castiello de Obeso, Santiago" userId="b4fc0b8e-1f0e-417a-8aad-015961d2398a" providerId="ADAL" clId="{2A3F39FC-901B-4154-829D-ABB3A00DA094}" dt="2025-03-06T15:18:02.839" v="1699" actId="47"/>
+    <pc:chgData name="Castiello de Obeso, Santiago" userId="b4fc0b8e-1f0e-417a-8aad-015961d2398a" providerId="ADAL" clId="{CDE771A2-018F-48D9-9343-246F847FC0D2}"/>
+    <pc:docChg chg="modSld">
+      <pc:chgData name="Castiello de Obeso, Santiago" userId="b4fc0b8e-1f0e-417a-8aad-015961d2398a" providerId="ADAL" clId="{CDE771A2-018F-48D9-9343-246F847FC0D2}" dt="2026-03-02T14:17:59.864" v="5" actId="20577"/>
       <pc:docMkLst>
         <pc:docMk/>
       </pc:docMkLst>
-      <pc:sldChg chg="addSp delSp modSp new del mod">
-        <pc:chgData name="Castiello de Obeso, Santiago" userId="b4fc0b8e-1f0e-417a-8aad-015961d2398a" providerId="ADAL" clId="{2A3F39FC-901B-4154-829D-ABB3A00DA094}" dt="2025-02-08T15:53:27.381" v="1210" actId="47"/>
-        <pc:sldMkLst>
-          <pc:docMk/>
-          <pc:sldMk cId="2310198615" sldId="256"/>
-        </pc:sldMkLst>
-      </pc:sldChg>
-      <pc:sldChg chg="addSp delSp modSp add del mod">
-        <pc:chgData name="Castiello de Obeso, Santiago" userId="b4fc0b8e-1f0e-417a-8aad-015961d2398a" providerId="ADAL" clId="{2A3F39FC-901B-4154-829D-ABB3A00DA094}" dt="2025-03-06T15:18:02.839" v="1699" actId="47"/>
-        <pc:sldMkLst>
-          <pc:docMk/>
-          <pc:sldMk cId="4023193392" sldId="257"/>
-        </pc:sldMkLst>
-      </pc:sldChg>
-      <pc:sldChg chg="addSp delSp modSp add del mod">
-        <pc:chgData name="Castiello de Obeso, Santiago" userId="b4fc0b8e-1f0e-417a-8aad-015961d2398a" providerId="ADAL" clId="{2A3F39FC-901B-4154-829D-ABB3A00DA094}" dt="2025-03-06T15:18:02.839" v="1699" actId="47"/>
-        <pc:sldMkLst>
-          <pc:docMk/>
-          <pc:sldMk cId="1821791587" sldId="258"/>
-        </pc:sldMkLst>
-      </pc:sldChg>
-      <pc:sldChg chg="addSp delSp modSp add mod">
-        <pc:chgData name="Castiello de Obeso, Santiago" userId="b4fc0b8e-1f0e-417a-8aad-015961d2398a" providerId="ADAL" clId="{2A3F39FC-901B-4154-829D-ABB3A00DA094}" dt="2025-03-06T14:31:40.122" v="1698" actId="21"/>
-        <pc:sldMkLst>
-          <pc:docMk/>
-          <pc:sldMk cId="2654144847" sldId="259"/>
-        </pc:sldMkLst>
-      </pc:sldChg>
-    </pc:docChg>
-  </pc:docChgLst>
-  <pc:docChgLst>
-    <pc:chgData name="Castiello de Obeso, Santiago" userId="b4fc0b8e-1f0e-417a-8aad-015961d2398a" providerId="ADAL" clId="{AE23CADE-1E1E-4A42-BA53-D7F25A2D2BFC}"/>
-    <pc:docChg chg="undo custSel addSld delSld modSld">
-      <pc:chgData name="Castiello de Obeso, Santiago" userId="b4fc0b8e-1f0e-417a-8aad-015961d2398a" providerId="ADAL" clId="{AE23CADE-1E1E-4A42-BA53-D7F25A2D2BFC}" dt="2025-08-26T14:32:41.088" v="542" actId="47"/>
-      <pc:docMkLst>
-        <pc:docMk/>
-      </pc:docMkLst>
-      <pc:sldChg chg="modSp del mod">
-        <pc:chgData name="Castiello de Obeso, Santiago" userId="b4fc0b8e-1f0e-417a-8aad-015961d2398a" providerId="ADAL" clId="{AE23CADE-1E1E-4A42-BA53-D7F25A2D2BFC}" dt="2025-08-26T14:32:39.868" v="540" actId="47"/>
-        <pc:sldMkLst>
-          <pc:docMk/>
-          <pc:sldMk cId="2654144847" sldId="259"/>
-        </pc:sldMkLst>
-      </pc:sldChg>
-      <pc:sldChg chg="addSp delSp modSp add del mod">
-        <pc:chgData name="Castiello de Obeso, Santiago" userId="b4fc0b8e-1f0e-417a-8aad-015961d2398a" providerId="ADAL" clId="{AE23CADE-1E1E-4A42-BA53-D7F25A2D2BFC}" dt="2025-08-26T14:32:41.088" v="542" actId="47"/>
+      <pc:sldChg chg="modSp mod">
+        <pc:chgData name="Castiello de Obeso, Santiago" userId="b4fc0b8e-1f0e-417a-8aad-015961d2398a" providerId="ADAL" clId="{CDE771A2-018F-48D9-9343-246F847FC0D2}" dt="2026-03-02T14:17:59.864" v="5" actId="20577"/>
         <pc:sldMkLst>
           <pc:docMk/>
           <pc:sldMk cId="1224849072" sldId="260"/>
         </pc:sldMkLst>
         <pc:spChg chg="mod">
-          <ac:chgData name="Castiello de Obeso, Santiago" userId="b4fc0b8e-1f0e-417a-8aad-015961d2398a" providerId="ADAL" clId="{AE23CADE-1E1E-4A42-BA53-D7F25A2D2BFC}" dt="2025-07-21T14:31:50.094" v="447" actId="1076"/>
-          <ac:spMkLst>
-            <pc:docMk/>
-            <pc:sldMk cId="1224849072" sldId="260"/>
-            <ac:spMk id="43" creationId="{538AE8B6-488B-BD32-09AA-5AD2BB188193}"/>
-          </ac:spMkLst>
-        </pc:spChg>
-        <pc:spChg chg="mod">
-          <ac:chgData name="Castiello de Obeso, Santiago" userId="b4fc0b8e-1f0e-417a-8aad-015961d2398a" providerId="ADAL" clId="{AE23CADE-1E1E-4A42-BA53-D7F25A2D2BFC}" dt="2025-07-21T14:31:38.002" v="446" actId="1076"/>
-          <ac:spMkLst>
-            <pc:docMk/>
-            <pc:sldMk cId="1224849072" sldId="260"/>
-            <ac:spMk id="44" creationId="{803C3CC7-A45D-E977-777A-E38D05787AEF}"/>
-          </ac:spMkLst>
-        </pc:spChg>
-        <pc:spChg chg="mod">
-          <ac:chgData name="Castiello de Obeso, Santiago" userId="b4fc0b8e-1f0e-417a-8aad-015961d2398a" providerId="ADAL" clId="{AE23CADE-1E1E-4A42-BA53-D7F25A2D2BFC}" dt="2025-07-22T15:16:15.395" v="511" actId="1076"/>
-          <ac:spMkLst>
-            <pc:docMk/>
-            <pc:sldMk cId="1224849072" sldId="260"/>
-            <ac:spMk id="76" creationId="{9E55844A-3E4C-98CF-4705-6451F0AE74F6}"/>
-          </ac:spMkLst>
-        </pc:spChg>
-        <pc:spChg chg="add mod">
-          <ac:chgData name="Castiello de Obeso, Santiago" userId="b4fc0b8e-1f0e-417a-8aad-015961d2398a" providerId="ADAL" clId="{AE23CADE-1E1E-4A42-BA53-D7F25A2D2BFC}" dt="2025-07-22T15:16:15.395" v="511" actId="1076"/>
+          <ac:chgData name="Castiello de Obeso, Santiago" userId="b4fc0b8e-1f0e-417a-8aad-015961d2398a" providerId="ADAL" clId="{CDE771A2-018F-48D9-9343-246F847FC0D2}" dt="2026-03-02T14:17:56.664" v="1" actId="20577"/>
           <ac:spMkLst>
             <pc:docMk/>
             <pc:sldMk cId="1224849072" sldId="260"/>
@@ -212,365 +136,13 @@
           </ac:spMkLst>
         </pc:spChg>
         <pc:spChg chg="mod">
-          <ac:chgData name="Castiello de Obeso, Santiago" userId="b4fc0b8e-1f0e-417a-8aad-015961d2398a" providerId="ADAL" clId="{AE23CADE-1E1E-4A42-BA53-D7F25A2D2BFC}" dt="2025-07-22T15:16:15.395" v="511" actId="1076"/>
-          <ac:spMkLst>
-            <pc:docMk/>
-            <pc:sldMk cId="1224849072" sldId="260"/>
-            <ac:spMk id="78" creationId="{BD1350A1-B17C-105A-AD56-623D97B49724}"/>
-          </ac:spMkLst>
-        </pc:spChg>
-        <pc:spChg chg="add mod">
-          <ac:chgData name="Castiello de Obeso, Santiago" userId="b4fc0b8e-1f0e-417a-8aad-015961d2398a" providerId="ADAL" clId="{AE23CADE-1E1E-4A42-BA53-D7F25A2D2BFC}" dt="2025-07-22T15:16:15.395" v="511" actId="1076"/>
-          <ac:spMkLst>
-            <pc:docMk/>
-            <pc:sldMk cId="1224849072" sldId="260"/>
-            <ac:spMk id="79" creationId="{A78486C1-0FD8-1E1A-ED92-F5CA34B8399D}"/>
-          </ac:spMkLst>
-        </pc:spChg>
-        <pc:spChg chg="add mod">
-          <ac:chgData name="Castiello de Obeso, Santiago" userId="b4fc0b8e-1f0e-417a-8aad-015961d2398a" providerId="ADAL" clId="{AE23CADE-1E1E-4A42-BA53-D7F25A2D2BFC}" dt="2025-07-22T15:16:15.395" v="511" actId="1076"/>
-          <ac:spMkLst>
-            <pc:docMk/>
-            <pc:sldMk cId="1224849072" sldId="260"/>
-            <ac:spMk id="85" creationId="{69CB4265-7258-0F27-6A94-0F4DD14CE0C4}"/>
-          </ac:spMkLst>
-        </pc:spChg>
-        <pc:spChg chg="mod">
-          <ac:chgData name="Castiello de Obeso, Santiago" userId="b4fc0b8e-1f0e-417a-8aad-015961d2398a" providerId="ADAL" clId="{AE23CADE-1E1E-4A42-BA53-D7F25A2D2BFC}" dt="2025-07-22T15:16:15.395" v="511" actId="1076"/>
+          <ac:chgData name="Castiello de Obeso, Santiago" userId="b4fc0b8e-1f0e-417a-8aad-015961d2398a" providerId="ADAL" clId="{CDE771A2-018F-48D9-9343-246F847FC0D2}" dt="2026-03-02T14:17:59.864" v="5" actId="20577"/>
           <ac:spMkLst>
             <pc:docMk/>
             <pc:sldMk cId="1224849072" sldId="260"/>
             <ac:spMk id="86" creationId="{51A3E293-2568-ED6E-FE39-61C400354232}"/>
           </ac:spMkLst>
         </pc:spChg>
-        <pc:spChg chg="mod">
-          <ac:chgData name="Castiello de Obeso, Santiago" userId="b4fc0b8e-1f0e-417a-8aad-015961d2398a" providerId="ADAL" clId="{AE23CADE-1E1E-4A42-BA53-D7F25A2D2BFC}" dt="2025-07-21T14:25:20.635" v="226"/>
-          <ac:spMkLst>
-            <pc:docMk/>
-            <pc:sldMk cId="1224849072" sldId="260"/>
-            <ac:spMk id="92" creationId="{BED71052-B67F-BFC5-ED9E-5DF33A9D3C65}"/>
-          </ac:spMkLst>
-        </pc:spChg>
-        <pc:spChg chg="mod">
-          <ac:chgData name="Castiello de Obeso, Santiago" userId="b4fc0b8e-1f0e-417a-8aad-015961d2398a" providerId="ADAL" clId="{AE23CADE-1E1E-4A42-BA53-D7F25A2D2BFC}" dt="2025-07-21T14:25:20.635" v="226"/>
-          <ac:spMkLst>
-            <pc:docMk/>
-            <pc:sldMk cId="1224849072" sldId="260"/>
-            <ac:spMk id="93" creationId="{B1821D25-1C37-5CA4-1AF3-E772D78327E5}"/>
-          </ac:spMkLst>
-        </pc:spChg>
-        <pc:spChg chg="add mod">
-          <ac:chgData name="Castiello de Obeso, Santiago" userId="b4fc0b8e-1f0e-417a-8aad-015961d2398a" providerId="ADAL" clId="{AE23CADE-1E1E-4A42-BA53-D7F25A2D2BFC}" dt="2025-07-22T15:16:28.763" v="512" actId="1076"/>
-          <ac:spMkLst>
-            <pc:docMk/>
-            <pc:sldMk cId="1224849072" sldId="260"/>
-            <ac:spMk id="170" creationId="{5626262A-BC22-69F0-F2EB-6D96EBAFE54A}"/>
-          </ac:spMkLst>
-        </pc:spChg>
-        <pc:spChg chg="add mod">
-          <ac:chgData name="Castiello de Obeso, Santiago" userId="b4fc0b8e-1f0e-417a-8aad-015961d2398a" providerId="ADAL" clId="{AE23CADE-1E1E-4A42-BA53-D7F25A2D2BFC}" dt="2025-07-22T15:16:28.763" v="512" actId="1076"/>
-          <ac:spMkLst>
-            <pc:docMk/>
-            <pc:sldMk cId="1224849072" sldId="260"/>
-            <ac:spMk id="171" creationId="{19AD26FF-937A-FCC0-9DEA-C6A2C419C7E2}"/>
-          </ac:spMkLst>
-        </pc:spChg>
-        <pc:spChg chg="add mod">
-          <ac:chgData name="Castiello de Obeso, Santiago" userId="b4fc0b8e-1f0e-417a-8aad-015961d2398a" providerId="ADAL" clId="{AE23CADE-1E1E-4A42-BA53-D7F25A2D2BFC}" dt="2025-07-22T15:16:28.763" v="512" actId="1076"/>
-          <ac:spMkLst>
-            <pc:docMk/>
-            <pc:sldMk cId="1224849072" sldId="260"/>
-            <ac:spMk id="172" creationId="{AB045455-325C-9B3E-AEBD-B5BBC1517101}"/>
-          </ac:spMkLst>
-        </pc:spChg>
-        <pc:spChg chg="add mod">
-          <ac:chgData name="Castiello de Obeso, Santiago" userId="b4fc0b8e-1f0e-417a-8aad-015961d2398a" providerId="ADAL" clId="{AE23CADE-1E1E-4A42-BA53-D7F25A2D2BFC}" dt="2025-07-22T15:16:28.763" v="512" actId="1076"/>
-          <ac:spMkLst>
-            <pc:docMk/>
-            <pc:sldMk cId="1224849072" sldId="260"/>
-            <ac:spMk id="173" creationId="{1D859D15-DA5E-85C1-EC4A-42FB98912E6D}"/>
-          </ac:spMkLst>
-        </pc:spChg>
-        <pc:spChg chg="add mod">
-          <ac:chgData name="Castiello de Obeso, Santiago" userId="b4fc0b8e-1f0e-417a-8aad-015961d2398a" providerId="ADAL" clId="{AE23CADE-1E1E-4A42-BA53-D7F25A2D2BFC}" dt="2025-07-22T15:16:28.763" v="512" actId="1076"/>
-          <ac:spMkLst>
-            <pc:docMk/>
-            <pc:sldMk cId="1224849072" sldId="260"/>
-            <ac:spMk id="174" creationId="{FF88FBEE-8940-9B75-5D6A-87CB2ED63345}"/>
-          </ac:spMkLst>
-        </pc:spChg>
-        <pc:spChg chg="add mod">
-          <ac:chgData name="Castiello de Obeso, Santiago" userId="b4fc0b8e-1f0e-417a-8aad-015961d2398a" providerId="ADAL" clId="{AE23CADE-1E1E-4A42-BA53-D7F25A2D2BFC}" dt="2025-07-22T15:16:28.763" v="512" actId="1076"/>
-          <ac:spMkLst>
-            <pc:docMk/>
-            <pc:sldMk cId="1224849072" sldId="260"/>
-            <ac:spMk id="175" creationId="{ACCB3A5A-5F06-AF37-6CB9-E10B7FD17ED9}"/>
-          </ac:spMkLst>
-        </pc:spChg>
-        <pc:spChg chg="mod">
-          <ac:chgData name="Castiello de Obeso, Santiago" userId="b4fc0b8e-1f0e-417a-8aad-015961d2398a" providerId="ADAL" clId="{AE23CADE-1E1E-4A42-BA53-D7F25A2D2BFC}" dt="2025-07-21T14:28:02.478" v="366"/>
-          <ac:spMkLst>
-            <pc:docMk/>
-            <pc:sldMk cId="1224849072" sldId="260"/>
-            <ac:spMk id="179" creationId="{88B34CB9-9A7C-DD4C-4E7A-6E053D2EE4D7}"/>
-          </ac:spMkLst>
-        </pc:spChg>
-        <pc:spChg chg="mod">
-          <ac:chgData name="Castiello de Obeso, Santiago" userId="b4fc0b8e-1f0e-417a-8aad-015961d2398a" providerId="ADAL" clId="{AE23CADE-1E1E-4A42-BA53-D7F25A2D2BFC}" dt="2025-07-21T14:28:02.478" v="366"/>
-          <ac:spMkLst>
-            <pc:docMk/>
-            <pc:sldMk cId="1224849072" sldId="260"/>
-            <ac:spMk id="180" creationId="{3A52034E-E05F-9E51-2A7E-A1CDB9224399}"/>
-          </ac:spMkLst>
-        </pc:spChg>
-        <pc:spChg chg="add mod">
-          <ac:chgData name="Castiello de Obeso, Santiago" userId="b4fc0b8e-1f0e-417a-8aad-015961d2398a" providerId="ADAL" clId="{AE23CADE-1E1E-4A42-BA53-D7F25A2D2BFC}" dt="2025-08-06T13:42:03.716" v="528" actId="20577"/>
-          <ac:spMkLst>
-            <pc:docMk/>
-            <pc:sldMk cId="1224849072" sldId="260"/>
-            <ac:spMk id="186" creationId="{BEF032A2-6003-68ED-F49F-0B6F845C118C}"/>
-          </ac:spMkLst>
-        </pc:spChg>
-        <pc:spChg chg="add mod">
-          <ac:chgData name="Castiello de Obeso, Santiago" userId="b4fc0b8e-1f0e-417a-8aad-015961d2398a" providerId="ADAL" clId="{AE23CADE-1E1E-4A42-BA53-D7F25A2D2BFC}" dt="2025-08-06T13:42:07.596" v="536" actId="20577"/>
-          <ac:spMkLst>
-            <pc:docMk/>
-            <pc:sldMk cId="1224849072" sldId="260"/>
-            <ac:spMk id="187" creationId="{1955CB17-AEAD-B2D9-625B-A952206ECD1F}"/>
-          </ac:spMkLst>
-        </pc:spChg>
-        <pc:spChg chg="add mod">
-          <ac:chgData name="Castiello de Obeso, Santiago" userId="b4fc0b8e-1f0e-417a-8aad-015961d2398a" providerId="ADAL" clId="{AE23CADE-1E1E-4A42-BA53-D7F25A2D2BFC}" dt="2025-07-22T15:16:08.188" v="510" actId="1038"/>
-          <ac:spMkLst>
-            <pc:docMk/>
-            <pc:sldMk cId="1224849072" sldId="260"/>
-            <ac:spMk id="188" creationId="{612E66B1-B7C8-48DF-8B33-23BE70D18688}"/>
-          </ac:spMkLst>
-        </pc:spChg>
-        <pc:spChg chg="add mod">
-          <ac:chgData name="Castiello de Obeso, Santiago" userId="b4fc0b8e-1f0e-417a-8aad-015961d2398a" providerId="ADAL" clId="{AE23CADE-1E1E-4A42-BA53-D7F25A2D2BFC}" dt="2025-07-22T15:16:08.188" v="510" actId="1038"/>
-          <ac:spMkLst>
-            <pc:docMk/>
-            <pc:sldMk cId="1224849072" sldId="260"/>
-            <ac:spMk id="189" creationId="{ECB424C5-25C7-A1C6-C701-C36341FECAC6}"/>
-          </ac:spMkLst>
-        </pc:spChg>
-        <pc:spChg chg="add mod">
-          <ac:chgData name="Castiello de Obeso, Santiago" userId="b4fc0b8e-1f0e-417a-8aad-015961d2398a" providerId="ADAL" clId="{AE23CADE-1E1E-4A42-BA53-D7F25A2D2BFC}" dt="2025-08-06T13:42:05.591" v="529"/>
-          <ac:spMkLst>
-            <pc:docMk/>
-            <pc:sldMk cId="1224849072" sldId="260"/>
-            <ac:spMk id="190" creationId="{E431D458-EF90-90C3-A29B-C7A739C1FC6D}"/>
-          </ac:spMkLst>
-        </pc:spChg>
-        <pc:spChg chg="add mod">
-          <ac:chgData name="Castiello de Obeso, Santiago" userId="b4fc0b8e-1f0e-417a-8aad-015961d2398a" providerId="ADAL" clId="{AE23CADE-1E1E-4A42-BA53-D7F25A2D2BFC}" dt="2025-08-06T13:42:10.485" v="537"/>
-          <ac:spMkLst>
-            <pc:docMk/>
-            <pc:sldMk cId="1224849072" sldId="260"/>
-            <ac:spMk id="191" creationId="{3FC2D38A-F51B-7E69-BA3C-15EA9D256BA7}"/>
-          </ac:spMkLst>
-        </pc:spChg>
-        <pc:spChg chg="mod">
-          <ac:chgData name="Castiello de Obeso, Santiago" userId="b4fc0b8e-1f0e-417a-8aad-015961d2398a" providerId="ADAL" clId="{AE23CADE-1E1E-4A42-BA53-D7F25A2D2BFC}" dt="2025-07-21T14:28:07.508" v="368"/>
-          <ac:spMkLst>
-            <pc:docMk/>
-            <pc:sldMk cId="1224849072" sldId="260"/>
-            <ac:spMk id="195" creationId="{D68EDF0C-DB8E-EEDA-E2A9-5D41965ABC11}"/>
-          </ac:spMkLst>
-        </pc:spChg>
-        <pc:spChg chg="mod">
-          <ac:chgData name="Castiello de Obeso, Santiago" userId="b4fc0b8e-1f0e-417a-8aad-015961d2398a" providerId="ADAL" clId="{AE23CADE-1E1E-4A42-BA53-D7F25A2D2BFC}" dt="2025-07-21T14:28:07.508" v="368"/>
-          <ac:spMkLst>
-            <pc:docMk/>
-            <pc:sldMk cId="1224849072" sldId="260"/>
-            <ac:spMk id="196" creationId="{202B1698-5536-F3FC-CBF8-D534135D2A19}"/>
-          </ac:spMkLst>
-        </pc:spChg>
-        <pc:spChg chg="add mod">
-          <ac:chgData name="Castiello de Obeso, Santiago" userId="b4fc0b8e-1f0e-417a-8aad-015961d2398a" providerId="ADAL" clId="{AE23CADE-1E1E-4A42-BA53-D7F25A2D2BFC}" dt="2025-07-21T14:31:58.973" v="448" actId="1076"/>
-          <ac:spMkLst>
-            <pc:docMk/>
-            <pc:sldMk cId="1224849072" sldId="260"/>
-            <ac:spMk id="205" creationId="{92340E75-BE2B-FB18-A979-C26D1495A47E}"/>
-          </ac:spMkLst>
-        </pc:spChg>
-        <pc:spChg chg="add mod">
-          <ac:chgData name="Castiello de Obeso, Santiago" userId="b4fc0b8e-1f0e-417a-8aad-015961d2398a" providerId="ADAL" clId="{AE23CADE-1E1E-4A42-BA53-D7F25A2D2BFC}" dt="2025-07-22T15:16:15.395" v="511" actId="1076"/>
-          <ac:spMkLst>
-            <pc:docMk/>
-            <pc:sldMk cId="1224849072" sldId="260"/>
-            <ac:spMk id="207" creationId="{3CEDA06F-FE5B-38CA-3506-B643DBF0F81C}"/>
-          </ac:spMkLst>
-        </pc:spChg>
-        <pc:spChg chg="add mod">
-          <ac:chgData name="Castiello de Obeso, Santiago" userId="b4fc0b8e-1f0e-417a-8aad-015961d2398a" providerId="ADAL" clId="{AE23CADE-1E1E-4A42-BA53-D7F25A2D2BFC}" dt="2025-07-29T14:54:13.137" v="520" actId="6549"/>
-          <ac:spMkLst>
-            <pc:docMk/>
-            <pc:sldMk cId="1224849072" sldId="260"/>
-            <ac:spMk id="212" creationId="{63B8C8F8-43F6-8994-3D69-B8FE3A4D1049}"/>
-          </ac:spMkLst>
-        </pc:spChg>
-        <pc:spChg chg="add mod">
-          <ac:chgData name="Castiello de Obeso, Santiago" userId="b4fc0b8e-1f0e-417a-8aad-015961d2398a" providerId="ADAL" clId="{AE23CADE-1E1E-4A42-BA53-D7F25A2D2BFC}" dt="2025-07-22T15:16:08.188" v="510" actId="1038"/>
-          <ac:spMkLst>
-            <pc:docMk/>
-            <pc:sldMk cId="1224849072" sldId="260"/>
-            <ac:spMk id="214" creationId="{54AF0165-F1BE-00D7-37C2-FA20BA0020E5}"/>
-          </ac:spMkLst>
-        </pc:spChg>
-        <pc:grpChg chg="mod">
-          <ac:chgData name="Castiello de Obeso, Santiago" userId="b4fc0b8e-1f0e-417a-8aad-015961d2398a" providerId="ADAL" clId="{AE23CADE-1E1E-4A42-BA53-D7F25A2D2BFC}" dt="2025-07-22T15:16:15.395" v="511" actId="1076"/>
-          <ac:grpSpMkLst>
-            <pc:docMk/>
-            <pc:sldMk cId="1224849072" sldId="260"/>
-            <ac:grpSpMk id="91" creationId="{D3F83303-FD52-7983-44E1-EC7C54DD8BFB}"/>
-          </ac:grpSpMkLst>
-        </pc:grpChg>
-        <pc:grpChg chg="add mod">
-          <ac:chgData name="Castiello de Obeso, Santiago" userId="b4fc0b8e-1f0e-417a-8aad-015961d2398a" providerId="ADAL" clId="{AE23CADE-1E1E-4A42-BA53-D7F25A2D2BFC}" dt="2025-07-22T15:16:28.763" v="512" actId="1076"/>
-          <ac:grpSpMkLst>
-            <pc:docMk/>
-            <pc:sldMk cId="1224849072" sldId="260"/>
-            <ac:grpSpMk id="178" creationId="{AC3B1C14-B3BE-F405-494E-6D28A2A6C9D6}"/>
-          </ac:grpSpMkLst>
-        </pc:grpChg>
-        <pc:grpChg chg="add mod">
-          <ac:chgData name="Castiello de Obeso, Santiago" userId="b4fc0b8e-1f0e-417a-8aad-015961d2398a" providerId="ADAL" clId="{AE23CADE-1E1E-4A42-BA53-D7F25A2D2BFC}" dt="2025-07-22T15:16:08.188" v="510" actId="1038"/>
-          <ac:grpSpMkLst>
-            <pc:docMk/>
-            <pc:sldMk cId="1224849072" sldId="260"/>
-            <ac:grpSpMk id="194" creationId="{D7DCB42A-CA4A-ABA7-960F-3A384C580014}"/>
-          </ac:grpSpMkLst>
-        </pc:grpChg>
-        <pc:cxnChg chg="mod">
-          <ac:chgData name="Castiello de Obeso, Santiago" userId="b4fc0b8e-1f0e-417a-8aad-015961d2398a" providerId="ADAL" clId="{AE23CADE-1E1E-4A42-BA53-D7F25A2D2BFC}" dt="2025-07-22T15:16:15.395" v="511" actId="1076"/>
-          <ac:cxnSpMkLst>
-            <pc:docMk/>
-            <pc:sldMk cId="1224849072" sldId="260"/>
-            <ac:cxnSpMk id="89" creationId="{8B4ACC4E-D9F7-49F5-F7E7-9DE3BB1AAEB8}"/>
-          </ac:cxnSpMkLst>
-        </pc:cxnChg>
-        <pc:cxnChg chg="mod">
-          <ac:chgData name="Castiello de Obeso, Santiago" userId="b4fc0b8e-1f0e-417a-8aad-015961d2398a" providerId="ADAL" clId="{AE23CADE-1E1E-4A42-BA53-D7F25A2D2BFC}" dt="2025-07-21T14:27:44.462" v="361" actId="1076"/>
-          <ac:cxnSpMkLst>
-            <pc:docMk/>
-            <pc:sldMk cId="1224849072" sldId="260"/>
-            <ac:cxnSpMk id="90" creationId="{14583604-B211-B042-999D-4A59EC472123}"/>
-          </ac:cxnSpMkLst>
-        </pc:cxnChg>
-        <pc:cxnChg chg="mod">
-          <ac:chgData name="Castiello de Obeso, Santiago" userId="b4fc0b8e-1f0e-417a-8aad-015961d2398a" providerId="ADAL" clId="{AE23CADE-1E1E-4A42-BA53-D7F25A2D2BFC}" dt="2025-07-22T15:16:15.395" v="511" actId="1076"/>
-          <ac:cxnSpMkLst>
-            <pc:docMk/>
-            <pc:sldMk cId="1224849072" sldId="260"/>
-            <ac:cxnSpMk id="107" creationId="{F34700B3-B28E-1CCD-514F-FD1E559F9C97}"/>
-          </ac:cxnSpMkLst>
-        </pc:cxnChg>
-        <pc:cxnChg chg="mod">
-          <ac:chgData name="Castiello de Obeso, Santiago" userId="b4fc0b8e-1f0e-417a-8aad-015961d2398a" providerId="ADAL" clId="{AE23CADE-1E1E-4A42-BA53-D7F25A2D2BFC}" dt="2025-07-21T14:26:41.312" v="245" actId="1076"/>
-          <ac:cxnSpMkLst>
-            <pc:docMk/>
-            <pc:sldMk cId="1224849072" sldId="260"/>
-            <ac:cxnSpMk id="110" creationId="{9E118143-C25C-5A44-C917-AC8138E5C343}"/>
-          </ac:cxnSpMkLst>
-        </pc:cxnChg>
-        <pc:cxnChg chg="mod">
-          <ac:chgData name="Castiello de Obeso, Santiago" userId="b4fc0b8e-1f0e-417a-8aad-015961d2398a" providerId="ADAL" clId="{AE23CADE-1E1E-4A42-BA53-D7F25A2D2BFC}" dt="2025-07-21T14:26:41.312" v="245" actId="1076"/>
-          <ac:cxnSpMkLst>
-            <pc:docMk/>
-            <pc:sldMk cId="1224849072" sldId="260"/>
-            <ac:cxnSpMk id="111" creationId="{4987CAFD-EFC8-317D-FA10-B07FE9FB3216}"/>
-          </ac:cxnSpMkLst>
-        </pc:cxnChg>
-        <pc:cxnChg chg="mod">
-          <ac:chgData name="Castiello de Obeso, Santiago" userId="b4fc0b8e-1f0e-417a-8aad-015961d2398a" providerId="ADAL" clId="{AE23CADE-1E1E-4A42-BA53-D7F25A2D2BFC}" dt="2025-07-21T14:26:50.713" v="246" actId="1076"/>
-          <ac:cxnSpMkLst>
-            <pc:docMk/>
-            <pc:sldMk cId="1224849072" sldId="260"/>
-            <ac:cxnSpMk id="115" creationId="{3C38AEC5-BE1A-005F-9C80-A5F72F2E77F6}"/>
-          </ac:cxnSpMkLst>
-        </pc:cxnChg>
-        <pc:cxnChg chg="add mod">
-          <ac:chgData name="Castiello de Obeso, Santiago" userId="b4fc0b8e-1f0e-417a-8aad-015961d2398a" providerId="ADAL" clId="{AE23CADE-1E1E-4A42-BA53-D7F25A2D2BFC}" dt="2025-07-22T15:16:28.763" v="512" actId="1076"/>
-          <ac:cxnSpMkLst>
-            <pc:docMk/>
-            <pc:sldMk cId="1224849072" sldId="260"/>
-            <ac:cxnSpMk id="182" creationId="{10785D4B-72D1-0A7F-C7B3-451329179E4B}"/>
-          </ac:cxnSpMkLst>
-        </pc:cxnChg>
-        <pc:cxnChg chg="mod">
-          <ac:chgData name="Castiello de Obeso, Santiago" userId="b4fc0b8e-1f0e-417a-8aad-015961d2398a" providerId="ADAL" clId="{AE23CADE-1E1E-4A42-BA53-D7F25A2D2BFC}" dt="2025-07-21T14:30:50.112" v="401" actId="1076"/>
-          <ac:cxnSpMkLst>
-            <pc:docMk/>
-            <pc:sldMk cId="1224849072" sldId="260"/>
-            <ac:cxnSpMk id="184" creationId="{7215CE42-6A79-FB39-D04A-593D57F2897D}"/>
-          </ac:cxnSpMkLst>
-        </pc:cxnChg>
-        <pc:cxnChg chg="mod">
-          <ac:chgData name="Castiello de Obeso, Santiago" userId="b4fc0b8e-1f0e-417a-8aad-015961d2398a" providerId="ADAL" clId="{AE23CADE-1E1E-4A42-BA53-D7F25A2D2BFC}" dt="2025-07-21T14:30:50.112" v="401" actId="1076"/>
-          <ac:cxnSpMkLst>
-            <pc:docMk/>
-            <pc:sldMk cId="1224849072" sldId="260"/>
-            <ac:cxnSpMk id="185" creationId="{DDF8D9B2-AA93-E235-9A23-73208B57C11F}"/>
-          </ac:cxnSpMkLst>
-        </pc:cxnChg>
-        <pc:cxnChg chg="add mod">
-          <ac:chgData name="Castiello de Obeso, Santiago" userId="b4fc0b8e-1f0e-417a-8aad-015961d2398a" providerId="ADAL" clId="{AE23CADE-1E1E-4A42-BA53-D7F25A2D2BFC}" dt="2025-07-22T15:16:08.188" v="510" actId="1038"/>
-          <ac:cxnSpMkLst>
-            <pc:docMk/>
-            <pc:sldMk cId="1224849072" sldId="260"/>
-            <ac:cxnSpMk id="197" creationId="{9AD5B131-CD96-EECC-C99E-065F555083DD}"/>
-          </ac:cxnSpMkLst>
-        </pc:cxnChg>
-        <pc:cxnChg chg="mod">
-          <ac:chgData name="Castiello de Obeso, Santiago" userId="b4fc0b8e-1f0e-417a-8aad-015961d2398a" providerId="ADAL" clId="{AE23CADE-1E1E-4A42-BA53-D7F25A2D2BFC}" dt="2025-07-22T15:16:08.188" v="510" actId="1038"/>
-          <ac:cxnSpMkLst>
-            <pc:docMk/>
-            <pc:sldMk cId="1224849072" sldId="260"/>
-            <ac:cxnSpMk id="198" creationId="{29B82110-1D56-9BDC-3B41-502B184857A8}"/>
-          </ac:cxnSpMkLst>
-        </pc:cxnChg>
-        <pc:cxnChg chg="mod">
-          <ac:chgData name="Castiello de Obeso, Santiago" userId="b4fc0b8e-1f0e-417a-8aad-015961d2398a" providerId="ADAL" clId="{AE23CADE-1E1E-4A42-BA53-D7F25A2D2BFC}" dt="2025-07-21T14:30:38.427" v="400" actId="1076"/>
-          <ac:cxnSpMkLst>
-            <pc:docMk/>
-            <pc:sldMk cId="1224849072" sldId="260"/>
-            <ac:cxnSpMk id="200" creationId="{269D2220-00C6-DD8B-88C2-E381971C561C}"/>
-          </ac:cxnSpMkLst>
-        </pc:cxnChg>
-        <pc:cxnChg chg="mod">
-          <ac:chgData name="Castiello de Obeso, Santiago" userId="b4fc0b8e-1f0e-417a-8aad-015961d2398a" providerId="ADAL" clId="{AE23CADE-1E1E-4A42-BA53-D7F25A2D2BFC}" dt="2025-07-21T14:30:28.180" v="399" actId="14100"/>
-          <ac:cxnSpMkLst>
-            <pc:docMk/>
-            <pc:sldMk cId="1224849072" sldId="260"/>
-            <ac:cxnSpMk id="201" creationId="{55940225-A1E1-93BF-EBB3-60E6551FF88D}"/>
-          </ac:cxnSpMkLst>
-        </pc:cxnChg>
-        <pc:cxnChg chg="add mod">
-          <ac:chgData name="Castiello de Obeso, Santiago" userId="b4fc0b8e-1f0e-417a-8aad-015961d2398a" providerId="ADAL" clId="{AE23CADE-1E1E-4A42-BA53-D7F25A2D2BFC}" dt="2025-07-22T15:14:42.600" v="469" actId="14100"/>
-          <ac:cxnSpMkLst>
-            <pc:docMk/>
-            <pc:sldMk cId="1224849072" sldId="260"/>
-            <ac:cxnSpMk id="209" creationId="{4F312682-C17B-5A63-7261-B2A8E0BFF3F1}"/>
-          </ac:cxnSpMkLst>
-        </pc:cxnChg>
-        <pc:cxnChg chg="add mod">
-          <ac:chgData name="Castiello de Obeso, Santiago" userId="b4fc0b8e-1f0e-417a-8aad-015961d2398a" providerId="ADAL" clId="{AE23CADE-1E1E-4A42-BA53-D7F25A2D2BFC}" dt="2025-07-22T15:16:28.763" v="512" actId="1076"/>
-          <ac:cxnSpMkLst>
-            <pc:docMk/>
-            <pc:sldMk cId="1224849072" sldId="260"/>
-            <ac:cxnSpMk id="213" creationId="{CA08CEB9-6D10-26DC-7F31-8EDE32DAD0C8}"/>
-          </ac:cxnSpMkLst>
-        </pc:cxnChg>
-        <pc:cxnChg chg="add mod">
-          <ac:chgData name="Castiello de Obeso, Santiago" userId="b4fc0b8e-1f0e-417a-8aad-015961d2398a" providerId="ADAL" clId="{AE23CADE-1E1E-4A42-BA53-D7F25A2D2BFC}" dt="2025-07-22T15:15:30.051" v="483" actId="1076"/>
-          <ac:cxnSpMkLst>
-            <pc:docMk/>
-            <pc:sldMk cId="1224849072" sldId="260"/>
-            <ac:cxnSpMk id="215" creationId="{FD963D25-2AD3-58DB-2067-D0685192DD51}"/>
-          </ac:cxnSpMkLst>
-        </pc:cxnChg>
       </pc:sldChg>
     </pc:docChg>
   </pc:docChgLst>
@@ -726,7 +298,7 @@
           <a:p>
             <a:fld id="{0AFA125D-6C16-440D-B65A-850231F6884E}" type="datetimeFigureOut">
               <a:rPr lang="en-GB" smtClean="0"/>
-              <a:t>26/08/2025</a:t>
+              <a:t>02/03/2026</a:t>
             </a:fld>
             <a:endParaRPr lang="en-GB"/>
           </a:p>
@@ -926,7 +498,7 @@
           <a:p>
             <a:fld id="{0AFA125D-6C16-440D-B65A-850231F6884E}" type="datetimeFigureOut">
               <a:rPr lang="en-GB" smtClean="0"/>
-              <a:t>26/08/2025</a:t>
+              <a:t>02/03/2026</a:t>
             </a:fld>
             <a:endParaRPr lang="en-GB"/>
           </a:p>
@@ -1136,7 +708,7 @@
           <a:p>
             <a:fld id="{0AFA125D-6C16-440D-B65A-850231F6884E}" type="datetimeFigureOut">
               <a:rPr lang="en-GB" smtClean="0"/>
-              <a:t>26/08/2025</a:t>
+              <a:t>02/03/2026</a:t>
             </a:fld>
             <a:endParaRPr lang="en-GB"/>
           </a:p>
@@ -1336,7 +908,7 @@
           <a:p>
             <a:fld id="{0AFA125D-6C16-440D-B65A-850231F6884E}" type="datetimeFigureOut">
               <a:rPr lang="en-GB" smtClean="0"/>
-              <a:t>26/08/2025</a:t>
+              <a:t>02/03/2026</a:t>
             </a:fld>
             <a:endParaRPr lang="en-GB"/>
           </a:p>
@@ -1612,7 +1184,7 @@
           <a:p>
             <a:fld id="{0AFA125D-6C16-440D-B65A-850231F6884E}" type="datetimeFigureOut">
               <a:rPr lang="en-GB" smtClean="0"/>
-              <a:t>26/08/2025</a:t>
+              <a:t>02/03/2026</a:t>
             </a:fld>
             <a:endParaRPr lang="en-GB"/>
           </a:p>
@@ -1880,7 +1452,7 @@
           <a:p>
             <a:fld id="{0AFA125D-6C16-440D-B65A-850231F6884E}" type="datetimeFigureOut">
               <a:rPr lang="en-GB" smtClean="0"/>
-              <a:t>26/08/2025</a:t>
+              <a:t>02/03/2026</a:t>
             </a:fld>
             <a:endParaRPr lang="en-GB"/>
           </a:p>
@@ -2295,7 +1867,7 @@
           <a:p>
             <a:fld id="{0AFA125D-6C16-440D-B65A-850231F6884E}" type="datetimeFigureOut">
               <a:rPr lang="en-GB" smtClean="0"/>
-              <a:t>26/08/2025</a:t>
+              <a:t>02/03/2026</a:t>
             </a:fld>
             <a:endParaRPr lang="en-GB"/>
           </a:p>
@@ -2437,7 +2009,7 @@
           <a:p>
             <a:fld id="{0AFA125D-6C16-440D-B65A-850231F6884E}" type="datetimeFigureOut">
               <a:rPr lang="en-GB" smtClean="0"/>
-              <a:t>26/08/2025</a:t>
+              <a:t>02/03/2026</a:t>
             </a:fld>
             <a:endParaRPr lang="en-GB"/>
           </a:p>
@@ -2550,7 +2122,7 @@
           <a:p>
             <a:fld id="{0AFA125D-6C16-440D-B65A-850231F6884E}" type="datetimeFigureOut">
               <a:rPr lang="en-GB" smtClean="0"/>
-              <a:t>26/08/2025</a:t>
+              <a:t>02/03/2026</a:t>
             </a:fld>
             <a:endParaRPr lang="en-GB"/>
           </a:p>
@@ -2863,7 +2435,7 @@
           <a:p>
             <a:fld id="{0AFA125D-6C16-440D-B65A-850231F6884E}" type="datetimeFigureOut">
               <a:rPr lang="en-GB" smtClean="0"/>
-              <a:t>26/08/2025</a:t>
+              <a:t>02/03/2026</a:t>
             </a:fld>
             <a:endParaRPr lang="en-GB"/>
           </a:p>
@@ -3152,7 +2724,7 @@
           <a:p>
             <a:fld id="{0AFA125D-6C16-440D-B65A-850231F6884E}" type="datetimeFigureOut">
               <a:rPr lang="en-GB" smtClean="0"/>
-              <a:t>26/08/2025</a:t>
+              <a:t>02/03/2026</a:t>
             </a:fld>
             <a:endParaRPr lang="en-GB"/>
           </a:p>
@@ -3395,7 +2967,7 @@
           <a:p>
             <a:fld id="{0AFA125D-6C16-440D-B65A-850231F6884E}" type="datetimeFigureOut">
               <a:rPr lang="en-GB" smtClean="0"/>
-              <a:t>26/08/2025</a:t>
+              <a:t>02/03/2026</a:t>
             </a:fld>
             <a:endParaRPr lang="en-GB"/>
           </a:p>
@@ -4007,7 +3579,7 @@
                   <a:srgbClr val="D55E00"/>
                 </a:solidFill>
               </a:rPr>
-              <a:t>Non-Anxious</a:t>
+              <a:t>Non-anxious</a:t>
             </a:r>
           </a:p>
         </p:txBody>
@@ -4235,7 +3807,7 @@
                   <a:srgbClr val="D55E00"/>
                 </a:solidFill>
               </a:rPr>
-              <a:t>Non-Anxious</a:t>
+              <a:t>Non-anxious</a:t>
             </a:r>
           </a:p>
         </p:txBody>

</xml_diff>